<commit_message>
Added toolbar in main widget
</commit_message>
<xml_diff>
--- a/icons/splashscreens.pptx
+++ b/icons/splashscreens.pptx
@@ -264,7 +264,7 @@
           <a:p>
             <a:fld id="{D95F3F3F-3E05-4475-BDF7-9F1F10448BC5}" type="datetimeFigureOut">
               <a:rPr lang="fr-FR" smtClean="0"/>
-              <a:t>19/11/2025</a:t>
+              <a:t>26/03/2026</a:t>
             </a:fld>
             <a:endParaRPr lang="fr-FR"/>
           </a:p>
@@ -462,7 +462,7 @@
           <a:p>
             <a:fld id="{D95F3F3F-3E05-4475-BDF7-9F1F10448BC5}" type="datetimeFigureOut">
               <a:rPr lang="fr-FR" smtClean="0"/>
-              <a:t>19/11/2025</a:t>
+              <a:t>26/03/2026</a:t>
             </a:fld>
             <a:endParaRPr lang="fr-FR"/>
           </a:p>
@@ -670,7 +670,7 @@
           <a:p>
             <a:fld id="{D95F3F3F-3E05-4475-BDF7-9F1F10448BC5}" type="datetimeFigureOut">
               <a:rPr lang="fr-FR" smtClean="0"/>
-              <a:t>19/11/2025</a:t>
+              <a:t>26/03/2026</a:t>
             </a:fld>
             <a:endParaRPr lang="fr-FR"/>
           </a:p>
@@ -868,7 +868,7 @@
           <a:p>
             <a:fld id="{D95F3F3F-3E05-4475-BDF7-9F1F10448BC5}" type="datetimeFigureOut">
               <a:rPr lang="fr-FR" smtClean="0"/>
-              <a:t>19/11/2025</a:t>
+              <a:t>26/03/2026</a:t>
             </a:fld>
             <a:endParaRPr lang="fr-FR"/>
           </a:p>
@@ -1143,7 +1143,7 @@
           <a:p>
             <a:fld id="{D95F3F3F-3E05-4475-BDF7-9F1F10448BC5}" type="datetimeFigureOut">
               <a:rPr lang="fr-FR" smtClean="0"/>
-              <a:t>19/11/2025</a:t>
+              <a:t>26/03/2026</a:t>
             </a:fld>
             <a:endParaRPr lang="fr-FR"/>
           </a:p>
@@ -1408,7 +1408,7 @@
           <a:p>
             <a:fld id="{D95F3F3F-3E05-4475-BDF7-9F1F10448BC5}" type="datetimeFigureOut">
               <a:rPr lang="fr-FR" smtClean="0"/>
-              <a:t>19/11/2025</a:t>
+              <a:t>26/03/2026</a:t>
             </a:fld>
             <a:endParaRPr lang="fr-FR"/>
           </a:p>
@@ -1820,7 +1820,7 @@
           <a:p>
             <a:fld id="{D95F3F3F-3E05-4475-BDF7-9F1F10448BC5}" type="datetimeFigureOut">
               <a:rPr lang="fr-FR" smtClean="0"/>
-              <a:t>19/11/2025</a:t>
+              <a:t>26/03/2026</a:t>
             </a:fld>
             <a:endParaRPr lang="fr-FR"/>
           </a:p>
@@ -1961,7 +1961,7 @@
           <a:p>
             <a:fld id="{D95F3F3F-3E05-4475-BDF7-9F1F10448BC5}" type="datetimeFigureOut">
               <a:rPr lang="fr-FR" smtClean="0"/>
-              <a:t>19/11/2025</a:t>
+              <a:t>26/03/2026</a:t>
             </a:fld>
             <a:endParaRPr lang="fr-FR"/>
           </a:p>
@@ -2074,7 +2074,7 @@
           <a:p>
             <a:fld id="{D95F3F3F-3E05-4475-BDF7-9F1F10448BC5}" type="datetimeFigureOut">
               <a:rPr lang="fr-FR" smtClean="0"/>
-              <a:t>19/11/2025</a:t>
+              <a:t>26/03/2026</a:t>
             </a:fld>
             <a:endParaRPr lang="fr-FR"/>
           </a:p>
@@ -2385,7 +2385,7 @@
           <a:p>
             <a:fld id="{D95F3F3F-3E05-4475-BDF7-9F1F10448BC5}" type="datetimeFigureOut">
               <a:rPr lang="fr-FR" smtClean="0"/>
-              <a:t>19/11/2025</a:t>
+              <a:t>26/03/2026</a:t>
             </a:fld>
             <a:endParaRPr lang="fr-FR"/>
           </a:p>
@@ -2673,7 +2673,7 @@
           <a:p>
             <a:fld id="{D95F3F3F-3E05-4475-BDF7-9F1F10448BC5}" type="datetimeFigureOut">
               <a:rPr lang="fr-FR" smtClean="0"/>
-              <a:t>19/11/2025</a:t>
+              <a:t>26/03/2026</a:t>
             </a:fld>
             <a:endParaRPr lang="fr-FR"/>
           </a:p>
@@ -2914,7 +2914,7 @@
           <a:p>
             <a:fld id="{D95F3F3F-3E05-4475-BDF7-9F1F10448BC5}" type="datetimeFigureOut">
               <a:rPr lang="fr-FR" smtClean="0"/>
-              <a:t>19/11/2025</a:t>
+              <a:t>26/03/2026</a:t>
             </a:fld>
             <a:endParaRPr lang="fr-FR"/>
           </a:p>
@@ -6126,6 +6126,115 @@
           </a:p>
         </p:txBody>
       </p:sp>
+      <p:sp>
+        <p:nvSpPr>
+          <p:cNvPr id="2" name="Ellipse 1">
+            <a:extLst>
+              <a:ext uri="{FF2B5EF4-FFF2-40B4-BE49-F238E27FC236}">
+                <a16:creationId xmlns:a16="http://schemas.microsoft.com/office/drawing/2014/main" id="{B4F18876-8957-428A-86CF-9D2223051B63}"/>
+              </a:ext>
+            </a:extLst>
+          </p:cNvPr>
+          <p:cNvSpPr/>
+          <p:nvPr/>
+        </p:nvSpPr>
+        <p:spPr>
+          <a:xfrm>
+            <a:off x="635000" y="592667"/>
+            <a:ext cx="180000" cy="180000"/>
+          </a:xfrm>
+          <a:prstGeom prst="ellipse">
+            <a:avLst/>
+          </a:prstGeom>
+          <a:solidFill>
+            <a:schemeClr val="bg1">
+              <a:lumMod val="95000"/>
+            </a:schemeClr>
+          </a:solidFill>
+          <a:ln>
+            <a:noFill/>
+          </a:ln>
+        </p:spPr>
+        <p:style>
+          <a:lnRef idx="2">
+            <a:schemeClr val="accent1">
+              <a:shade val="50000"/>
+            </a:schemeClr>
+          </a:lnRef>
+          <a:fillRef idx="1">
+            <a:schemeClr val="accent1"/>
+          </a:fillRef>
+          <a:effectRef idx="0">
+            <a:schemeClr val="accent1"/>
+          </a:effectRef>
+          <a:fontRef idx="minor">
+            <a:schemeClr val="lt1"/>
+          </a:fontRef>
+        </p:style>
+        <p:txBody>
+          <a:bodyPr lIns="0" tIns="0" rIns="0" bIns="0" rtlCol="0" anchor="ctr"/>
+          <a:lstStyle/>
+          <a:p>
+            <a:pPr algn="ctr"/>
+            <a:endParaRPr lang="en-US" sz="500" b="1" dirty="0">
+              <a:solidFill>
+                <a:schemeClr val="tx1"/>
+              </a:solidFill>
+              <a:latin typeface="Arial Narrow" panose="020B0606020202030204" pitchFamily="34" charset="0"/>
+            </a:endParaRPr>
+          </a:p>
+        </p:txBody>
+      </p:sp>
+      <p:sp>
+        <p:nvSpPr>
+          <p:cNvPr id="9" name="ZoneTexte 8">
+            <a:extLst>
+              <a:ext uri="{FF2B5EF4-FFF2-40B4-BE49-F238E27FC236}">
+                <a16:creationId xmlns:a16="http://schemas.microsoft.com/office/drawing/2014/main" id="{DF667AF5-B6C6-47E2-AD8B-BE3394C7D968}"/>
+              </a:ext>
+            </a:extLst>
+          </p:cNvPr>
+          <p:cNvSpPr txBox="1"/>
+          <p:nvPr/>
+        </p:nvSpPr>
+        <p:spPr>
+          <a:xfrm>
+            <a:off x="645624" y="648405"/>
+            <a:ext cx="153989" cy="76944"/>
+          </a:xfrm>
+          <a:prstGeom prst="rect">
+            <a:avLst/>
+          </a:prstGeom>
+          <a:noFill/>
+        </p:spPr>
+        <p:txBody>
+          <a:bodyPr wrap="square" lIns="0" tIns="0" rIns="0" bIns="0">
+            <a:spAutoFit/>
+          </a:bodyPr>
+          <a:lstStyle/>
+          <a:p>
+            <a:pPr algn="ctr"/>
+            <a:r>
+              <a:rPr kumimoji="0" lang="en-US" sz="500" b="1" i="0" u="none" strike="noStrike" kern="1200" cap="none" spc="0" normalizeH="0" baseline="0" noProof="0" dirty="0">
+                <a:ln>
+                  <a:noFill/>
+                </a:ln>
+                <a:solidFill>
+                  <a:prstClr val="black"/>
+                </a:solidFill>
+                <a:effectLst/>
+                <a:uLnTx/>
+                <a:uFillTx/>
+                <a:latin typeface="Arial Narrow" panose="020B0606020202030204" pitchFamily="34" charset="0"/>
+                <a:ea typeface="+mn-ea"/>
+                <a:cs typeface="+mn-cs"/>
+              </a:rPr>
+              <a:t>TSM</a:t>
+            </a:r>
+            <a:endParaRPr lang="en-US" dirty="0"/>
+          </a:p>
+        </p:txBody>
+      </p:sp>
     </p:spTree>
     <p:extLst>
       <p:ext uri="{BB962C8B-B14F-4D97-AF65-F5344CB8AC3E}">

</xml_diff>

<commit_message>
Added back Python algorithms. Updated splashscreen. Added debugging print in main.
</commit_message>
<xml_diff>
--- a/icons/splashscreens.pptx
+++ b/icons/splashscreens.pptx
@@ -264,7 +264,7 @@
           <a:p>
             <a:fld id="{D95F3F3F-3E05-4475-BDF7-9F1F10448BC5}" type="datetimeFigureOut">
               <a:rPr lang="fr-FR" smtClean="0"/>
-              <a:t>27/03/2026</a:t>
+              <a:t>07/05/2026</a:t>
             </a:fld>
             <a:endParaRPr lang="fr-FR"/>
           </a:p>
@@ -462,7 +462,7 @@
           <a:p>
             <a:fld id="{D95F3F3F-3E05-4475-BDF7-9F1F10448BC5}" type="datetimeFigureOut">
               <a:rPr lang="fr-FR" smtClean="0"/>
-              <a:t>27/03/2026</a:t>
+              <a:t>07/05/2026</a:t>
             </a:fld>
             <a:endParaRPr lang="fr-FR"/>
           </a:p>
@@ -670,7 +670,7 @@
           <a:p>
             <a:fld id="{D95F3F3F-3E05-4475-BDF7-9F1F10448BC5}" type="datetimeFigureOut">
               <a:rPr lang="fr-FR" smtClean="0"/>
-              <a:t>27/03/2026</a:t>
+              <a:t>07/05/2026</a:t>
             </a:fld>
             <a:endParaRPr lang="fr-FR"/>
           </a:p>
@@ -868,7 +868,7 @@
           <a:p>
             <a:fld id="{D95F3F3F-3E05-4475-BDF7-9F1F10448BC5}" type="datetimeFigureOut">
               <a:rPr lang="fr-FR" smtClean="0"/>
-              <a:t>27/03/2026</a:t>
+              <a:t>07/05/2026</a:t>
             </a:fld>
             <a:endParaRPr lang="fr-FR"/>
           </a:p>
@@ -1143,7 +1143,7 @@
           <a:p>
             <a:fld id="{D95F3F3F-3E05-4475-BDF7-9F1F10448BC5}" type="datetimeFigureOut">
               <a:rPr lang="fr-FR" smtClean="0"/>
-              <a:t>27/03/2026</a:t>
+              <a:t>07/05/2026</a:t>
             </a:fld>
             <a:endParaRPr lang="fr-FR"/>
           </a:p>
@@ -1408,7 +1408,7 @@
           <a:p>
             <a:fld id="{D95F3F3F-3E05-4475-BDF7-9F1F10448BC5}" type="datetimeFigureOut">
               <a:rPr lang="fr-FR" smtClean="0"/>
-              <a:t>27/03/2026</a:t>
+              <a:t>07/05/2026</a:t>
             </a:fld>
             <a:endParaRPr lang="fr-FR"/>
           </a:p>
@@ -1820,7 +1820,7 @@
           <a:p>
             <a:fld id="{D95F3F3F-3E05-4475-BDF7-9F1F10448BC5}" type="datetimeFigureOut">
               <a:rPr lang="fr-FR" smtClean="0"/>
-              <a:t>27/03/2026</a:t>
+              <a:t>07/05/2026</a:t>
             </a:fld>
             <a:endParaRPr lang="fr-FR"/>
           </a:p>
@@ -1961,7 +1961,7 @@
           <a:p>
             <a:fld id="{D95F3F3F-3E05-4475-BDF7-9F1F10448BC5}" type="datetimeFigureOut">
               <a:rPr lang="fr-FR" smtClean="0"/>
-              <a:t>27/03/2026</a:t>
+              <a:t>07/05/2026</a:t>
             </a:fld>
             <a:endParaRPr lang="fr-FR"/>
           </a:p>
@@ -2074,7 +2074,7 @@
           <a:p>
             <a:fld id="{D95F3F3F-3E05-4475-BDF7-9F1F10448BC5}" type="datetimeFigureOut">
               <a:rPr lang="fr-FR" smtClean="0"/>
-              <a:t>27/03/2026</a:t>
+              <a:t>07/05/2026</a:t>
             </a:fld>
             <a:endParaRPr lang="fr-FR"/>
           </a:p>
@@ -2385,7 +2385,7 @@
           <a:p>
             <a:fld id="{D95F3F3F-3E05-4475-BDF7-9F1F10448BC5}" type="datetimeFigureOut">
               <a:rPr lang="fr-FR" smtClean="0"/>
-              <a:t>27/03/2026</a:t>
+              <a:t>07/05/2026</a:t>
             </a:fld>
             <a:endParaRPr lang="fr-FR"/>
           </a:p>
@@ -2673,7 +2673,7 @@
           <a:p>
             <a:fld id="{D95F3F3F-3E05-4475-BDF7-9F1F10448BC5}" type="datetimeFigureOut">
               <a:rPr lang="fr-FR" smtClean="0"/>
-              <a:t>27/03/2026</a:t>
+              <a:t>07/05/2026</a:t>
             </a:fld>
             <a:endParaRPr lang="fr-FR"/>
           </a:p>
@@ -2914,7 +2914,7 @@
           <a:p>
             <a:fld id="{D95F3F3F-3E05-4475-BDF7-9F1F10448BC5}" type="datetimeFigureOut">
               <a:rPr lang="fr-FR" smtClean="0"/>
-              <a:t>27/03/2026</a:t>
+              <a:t>07/05/2026</a:t>
             </a:fld>
             <a:endParaRPr lang="fr-FR"/>
           </a:p>
@@ -4845,7 +4845,7 @@
                 <a:latin typeface="+mj-lt"/>
                 <a:cs typeface="Arial" panose="020B0604020202020204" pitchFamily="34" charset="0"/>
               </a:rPr>
-              <a:t> 2025</a:t>
+              <a:t> 2026</a:t>
             </a:r>
           </a:p>
         </p:txBody>

</xml_diff>

<commit_message>
Correction in VipPlayerDBAccess::camera(): the right view name is now used. Modification in VipPlotPlayer: time scale data times are no longer rotated. Added VipPlotPlayer::lastClickedPoint() and VipPlotPlayer::lastGlobalClickedPoint() members. Use VipPlotPlayer::lastGlobalClickedPoint() in VipPlotPlayer::timeUnitChanged(). Added Python function clicked_point() in Thermavip module. Added VipAbstractScale::setMinimumBounds() and VipAbstractScale::setMaximumBounds() members. Now use vipStaticInit() macro to intialize global static variables.
</commit_message>
<xml_diff>
--- a/icons/splashscreens.pptx
+++ b/icons/splashscreens.pptx
@@ -264,7 +264,7 @@
           <a:p>
             <a:fld id="{D95F3F3F-3E05-4475-BDF7-9F1F10448BC5}" type="datetimeFigureOut">
               <a:rPr lang="fr-FR" smtClean="0"/>
-              <a:t>07/05/2026</a:t>
+              <a:t>09/06/2026</a:t>
             </a:fld>
             <a:endParaRPr lang="fr-FR"/>
           </a:p>
@@ -462,7 +462,7 @@
           <a:p>
             <a:fld id="{D95F3F3F-3E05-4475-BDF7-9F1F10448BC5}" type="datetimeFigureOut">
               <a:rPr lang="fr-FR" smtClean="0"/>
-              <a:t>07/05/2026</a:t>
+              <a:t>09/06/2026</a:t>
             </a:fld>
             <a:endParaRPr lang="fr-FR"/>
           </a:p>
@@ -670,7 +670,7 @@
           <a:p>
             <a:fld id="{D95F3F3F-3E05-4475-BDF7-9F1F10448BC5}" type="datetimeFigureOut">
               <a:rPr lang="fr-FR" smtClean="0"/>
-              <a:t>07/05/2026</a:t>
+              <a:t>09/06/2026</a:t>
             </a:fld>
             <a:endParaRPr lang="fr-FR"/>
           </a:p>
@@ -868,7 +868,7 @@
           <a:p>
             <a:fld id="{D95F3F3F-3E05-4475-BDF7-9F1F10448BC5}" type="datetimeFigureOut">
               <a:rPr lang="fr-FR" smtClean="0"/>
-              <a:t>07/05/2026</a:t>
+              <a:t>09/06/2026</a:t>
             </a:fld>
             <a:endParaRPr lang="fr-FR"/>
           </a:p>
@@ -1143,7 +1143,7 @@
           <a:p>
             <a:fld id="{D95F3F3F-3E05-4475-BDF7-9F1F10448BC5}" type="datetimeFigureOut">
               <a:rPr lang="fr-FR" smtClean="0"/>
-              <a:t>07/05/2026</a:t>
+              <a:t>09/06/2026</a:t>
             </a:fld>
             <a:endParaRPr lang="fr-FR"/>
           </a:p>
@@ -1408,7 +1408,7 @@
           <a:p>
             <a:fld id="{D95F3F3F-3E05-4475-BDF7-9F1F10448BC5}" type="datetimeFigureOut">
               <a:rPr lang="fr-FR" smtClean="0"/>
-              <a:t>07/05/2026</a:t>
+              <a:t>09/06/2026</a:t>
             </a:fld>
             <a:endParaRPr lang="fr-FR"/>
           </a:p>
@@ -1820,7 +1820,7 @@
           <a:p>
             <a:fld id="{D95F3F3F-3E05-4475-BDF7-9F1F10448BC5}" type="datetimeFigureOut">
               <a:rPr lang="fr-FR" smtClean="0"/>
-              <a:t>07/05/2026</a:t>
+              <a:t>09/06/2026</a:t>
             </a:fld>
             <a:endParaRPr lang="fr-FR"/>
           </a:p>
@@ -1961,7 +1961,7 @@
           <a:p>
             <a:fld id="{D95F3F3F-3E05-4475-BDF7-9F1F10448BC5}" type="datetimeFigureOut">
               <a:rPr lang="fr-FR" smtClean="0"/>
-              <a:t>07/05/2026</a:t>
+              <a:t>09/06/2026</a:t>
             </a:fld>
             <a:endParaRPr lang="fr-FR"/>
           </a:p>
@@ -2074,7 +2074,7 @@
           <a:p>
             <a:fld id="{D95F3F3F-3E05-4475-BDF7-9F1F10448BC5}" type="datetimeFigureOut">
               <a:rPr lang="fr-FR" smtClean="0"/>
-              <a:t>07/05/2026</a:t>
+              <a:t>09/06/2026</a:t>
             </a:fld>
             <a:endParaRPr lang="fr-FR"/>
           </a:p>
@@ -2385,7 +2385,7 @@
           <a:p>
             <a:fld id="{D95F3F3F-3E05-4475-BDF7-9F1F10448BC5}" type="datetimeFigureOut">
               <a:rPr lang="fr-FR" smtClean="0"/>
-              <a:t>07/05/2026</a:t>
+              <a:t>09/06/2026</a:t>
             </a:fld>
             <a:endParaRPr lang="fr-FR"/>
           </a:p>
@@ -2673,7 +2673,7 @@
           <a:p>
             <a:fld id="{D95F3F3F-3E05-4475-BDF7-9F1F10448BC5}" type="datetimeFigureOut">
               <a:rPr lang="fr-FR" smtClean="0"/>
-              <a:t>07/05/2026</a:t>
+              <a:t>09/06/2026</a:t>
             </a:fld>
             <a:endParaRPr lang="fr-FR"/>
           </a:p>
@@ -2914,7 +2914,7 @@
           <a:p>
             <a:fld id="{D95F3F3F-3E05-4475-BDF7-9F1F10448BC5}" type="datetimeFigureOut">
               <a:rPr lang="fr-FR" smtClean="0"/>
-              <a:t>07/05/2026</a:t>
+              <a:t>09/06/2026</a:t>
             </a:fld>
             <a:endParaRPr lang="fr-FR"/>
           </a:p>
@@ -7047,7 +7047,7 @@
                 <a:latin typeface="+mj-lt"/>
                 <a:cs typeface="Arial" panose="020B0604020202020204" pitchFamily="34" charset="0"/>
               </a:rPr>
-              <a:t> 2025</a:t>
+              <a:t> 2026</a:t>
             </a:r>
           </a:p>
         </p:txBody>

</xml_diff>